<commit_message>
Docs: web UI, Bedrock provider, AWS deployment and live demo URL
</commit_message>
<xml_diff>
--- a/docs/Capstone_Presentation.pptx
+++ b/docs/Capstone_Presentation.pptx
@@ -17,6 +17,7 @@
     <p:sldId id="265" r:id="rId17"/>
     <p:sldId id="266" r:id="rId18"/>
     <p:sldId id="267" r:id="rId19"/>
+    <p:sldId id="268" r:id="rId20"/>
   </p:sldIdLst>
   <p:sldSz cx="12191695" cy="6858000" type="screen4x3"/>
   <p:notesSz cx="6858000" cy="9144000"/>
@@ -583,7 +584,7 @@
           <a:lstStyle/>
           <a:p>
             <a:r>
-              <a:t>Data from output/final_report.csv and run_summary.json. Escalations were flagged for the laptop defect, late TV delivery and unpaid refund; the pure enquiry (006) was correctly marked is_complaint = No.</a:t>
+              <a:t>Table data from output/final_report.csv and run_summary.json (local Ollama glm-4.7-flash). Escalations were flagged for the laptop defect, late TV delivery and unpaid refund; the pure enquiry (006) was correctly marked is_complaint = No. The same batch on AWS Bedrock Nova 2 Lite took 8.6 s instead of 127.4 s with the same 6 success / 1 failed result and the same contact, category and flag values.</a:t>
             </a:r>
           </a:p>
         </p:txBody>
@@ -653,7 +654,7 @@
           <a:lstStyle/>
           <a:p>
             <a:r>
-              <a:t>Switching providers is a one-line .env change. Tests cover ingestion, JSON repair, retries, guardrails, parallelism and failure isolation without calling a real LLM.</a:t>
+              <a:t>Switching providers is a one-line .env change (LLM_PROVIDER=bedrock uses the AWS credential chain). Tests cover ingestion, JSON repair, retries, guardrails, parallelism and failure isolation without calling a real LLM.</a:t>
             </a:r>
           </a:p>
         </p:txBody>
@@ -723,6 +724,76 @@
           <a:lstStyle/>
           <a:p>
             <a:r>
+              <a:t>The Streamlit app runs in a Docker container on a small Graviton EC2 instance. The container calls Amazon Bedrock (Nova 2 Lite) with credentials from the instance's IAM role, so no API keys live on the server. User-data clones the public GitHub repo, builds the image and runs it on port 80 with --restart unless-stopped; redeploys run redeploy.sh through SSM Run Command.</a:t>
+            </a:r>
+          </a:p>
+        </p:txBody>
+      </p:sp>
+      <p:sp>
+        <p:nvSpPr>
+          <p:cNvPr id="4" name="Slide Number Placeholder 3"/>
+          <p:cNvSpPr>
+            <a:spLocks noGrp="1"/>
+          </p:cNvSpPr>
+          <p:nvPr>
+            <p:ph type="sldNum" idx="5" sz="quarter"/>
+          </p:nvPr>
+        </p:nvSpPr>
+        <p:spPr/>
+      </p:sp>
+    </p:spTree>
+  </p:cSld>
+  <p:clrMapOvr>
+    <a:masterClrMapping/>
+  </p:clrMapOvr>
+</p:notes>
+</file>
+
+<file path=ppt/notesSlides/notesSlide13.xml><?xml version="1.0" encoding="utf-8"?>
+<p:notes xmlns:a="http://schemas.openxmlformats.org/drawingml/2006/main" xmlns:p="http://schemas.openxmlformats.org/presentationml/2006/main" xmlns:r="http://schemas.openxmlformats.org/officeDocument/2006/relationships">
+  <p:cSld>
+    <p:spTree>
+      <p:nvGrpSpPr>
+        <p:cNvPr id="1" name=""/>
+        <p:cNvGrpSpPr/>
+        <p:nvPr/>
+      </p:nvGrpSpPr>
+      <p:grpSpPr>
+        <a:xfrm>
+          <a:off x="0" y="0"/>
+          <a:ext cx="0" cy="0"/>
+          <a:chOff x="0" y="0"/>
+          <a:chExt cx="0" cy="0"/>
+        </a:xfrm>
+      </p:grpSpPr>
+      <p:sp>
+        <p:nvSpPr>
+          <p:cNvPr id="2" name="Slide Image Placeholder 1"/>
+          <p:cNvSpPr>
+            <a:spLocks noGrp="1"/>
+          </p:cNvSpPr>
+          <p:nvPr>
+            <p:ph type="sldImg" idx="2"/>
+          </p:nvPr>
+        </p:nvSpPr>
+        <p:spPr/>
+      </p:sp>
+      <p:sp>
+        <p:nvSpPr>
+          <p:cNvPr id="3" name="Notes Placeholder 2"/>
+          <p:cNvSpPr>
+            <a:spLocks noGrp="1"/>
+          </p:cNvSpPr>
+          <p:nvPr>
+            <p:ph type="body" idx="3" sz="quarter"/>
+          </p:nvPr>
+        </p:nvSpPr>
+        <p:spPr/>
+        <p:txBody>
+          <a:bodyPr/>
+          <a:lstStyle/>
+          <a:p>
+            <a:r>
               <a:t>Closing: the system is working end to end; next steps focus on OCR, evaluation metrics and integration with a real ticketing system.</a:t>
             </a:r>
           </a:p>
@@ -933,7 +1004,7 @@
           <a:lstStyle/>
           <a:p>
             <a:r>
-              <a:t>Ingestion loads and normalises files; the pipeline runs extraction then a RunnableParallel of email and summary; writers persist everything. The LLM is injected via a provider-agnostic factory configured from .env.</a:t>
+              <a:t>Ingestion loads and normalises files; the pipeline runs extraction then a RunnableParallel of email and summary; writers persist everything. The LLM is injected via a provider-agnostic factory configured from .env (OpenAI, Gemini, local Ollama or AWS Bedrock).</a:t>
             </a:r>
           </a:p>
         </p:txBody>
@@ -4610,7 +4681,7 @@
                 </a:solidFill>
                 <a:latin typeface="Calibri"/>
               </a:rPr>
-              <a:t>Python • LangChain • Pydantic</a:t>
+              <a:t>Python • LangChain • Pydantic • AWS</a:t>
             </a:r>
           </a:p>
         </p:txBody>
@@ -4759,7 +4830,7 @@
                 </a:solidFill>
                 <a:latin typeface="Calibri"/>
               </a:rPr>
-              <a:t>Results: Real Run (Ollama glm-4.7-flash, local)</a:t>
+              <a:t>Results: Real Run + Provider Comparison</a:t>
             </a:r>
           </a:p>
         </p:txBody>
@@ -4837,7 +4908,7 @@
                 </a:solidFill>
                 <a:latin typeface="Calibri"/>
               </a:rPr>
-              <a:t>10 / 12</a:t>
+              <a:t>10 / 13</a:t>
             </a:r>
           </a:p>
         </p:txBody>
@@ -5985,7 +6056,247 @@
       </p:sp>
       <p:sp>
         <p:nvSpPr>
-          <p:cNvPr id="9" name="Rounded Rectangle 8"/>
+          <p:cNvPr id="9" name="TextBox 8"/>
+          <p:cNvSpPr txBox="1"/>
+          <p:nvPr/>
+        </p:nvSpPr>
+        <p:spPr>
+          <a:xfrm>
+            <a:off x="457200" y="5486400"/>
+            <a:ext cx="3291840" cy="365760"/>
+          </a:xfrm>
+          <a:prstGeom prst="rect">
+            <a:avLst/>
+          </a:prstGeom>
+          <a:noFill/>
+        </p:spPr>
+        <p:txBody>
+          <a:bodyPr wrap="square" anchor="ctr" lIns="45720" rIns="45720">
+            <a:spAutoFit/>
+          </a:bodyPr>
+          <a:lstStyle/>
+          <a:p>
+            <a:pPr algn="l">
+              <a:spcAft>
+                <a:spcPts val="400"/>
+              </a:spcAft>
+            </a:pPr>
+            <a:r>
+              <a:rPr sz="1200" b="1" i="0">
+                <a:solidFill>
+                  <a:srgbClr val="1F2937"/>
+                </a:solidFill>
+                <a:latin typeface="Calibri"/>
+              </a:rPr>
+              <a:t>Ollama glm-4.7-flash (local, 3 workers)</a:t>
+            </a:r>
+          </a:p>
+        </p:txBody>
+      </p:sp>
+      <p:sp>
+        <p:nvSpPr>
+          <p:cNvPr id="10" name="Rectangle 9"/>
+          <p:cNvSpPr/>
+          <p:nvPr/>
+        </p:nvSpPr>
+        <p:spPr>
+          <a:xfrm>
+            <a:off x="3794760" y="5550408"/>
+            <a:ext cx="3566160" cy="237744"/>
+          </a:xfrm>
+          <a:prstGeom prst="rect">
+            <a:avLst/>
+          </a:prstGeom>
+          <a:solidFill>
+            <a:srgbClr val="556070"/>
+          </a:solidFill>
+          <a:ln>
+            <a:noFill/>
+          </a:ln>
+          <a:effectLst/>
+        </p:spPr>
+        <p:style>
+          <a:lnRef idx="1">
+            <a:schemeClr val="accent1"/>
+          </a:lnRef>
+          <a:fillRef idx="3">
+            <a:schemeClr val="accent1"/>
+          </a:fillRef>
+          <a:effectRef idx="2">
+            <a:schemeClr val="accent1"/>
+          </a:effectRef>
+          <a:fontRef idx="minor">
+            <a:schemeClr val="lt1"/>
+          </a:fontRef>
+        </p:style>
+        <p:txBody>
+          <a:bodyPr rtlCol="0" anchor="ctr"/>
+          <a:lstStyle/>
+          <a:p/>
+        </p:txBody>
+      </p:sp>
+      <p:sp>
+        <p:nvSpPr>
+          <p:cNvPr id="11" name="TextBox 10"/>
+          <p:cNvSpPr txBox="1"/>
+          <p:nvPr/>
+        </p:nvSpPr>
+        <p:spPr>
+          <a:xfrm>
+            <a:off x="7406640" y="5486400"/>
+            <a:ext cx="914400" cy="365760"/>
+          </a:xfrm>
+          <a:prstGeom prst="rect">
+            <a:avLst/>
+          </a:prstGeom>
+          <a:noFill/>
+        </p:spPr>
+        <p:txBody>
+          <a:bodyPr wrap="square" anchor="ctr" lIns="45720" rIns="45720">
+            <a:spAutoFit/>
+          </a:bodyPr>
+          <a:lstStyle/>
+          <a:p>
+            <a:pPr algn="l">
+              <a:spcAft>
+                <a:spcPts val="400"/>
+              </a:spcAft>
+            </a:pPr>
+            <a:r>
+              <a:rPr sz="1200" b="1" i="0">
+                <a:solidFill>
+                  <a:srgbClr val="0F1F3D"/>
+                </a:solidFill>
+                <a:latin typeface="Calibri"/>
+              </a:rPr>
+              <a:t>127.4 s</a:t>
+            </a:r>
+          </a:p>
+        </p:txBody>
+      </p:sp>
+      <p:sp>
+        <p:nvSpPr>
+          <p:cNvPr id="12" name="TextBox 11"/>
+          <p:cNvSpPr txBox="1"/>
+          <p:nvPr/>
+        </p:nvSpPr>
+        <p:spPr>
+          <a:xfrm>
+            <a:off x="457200" y="5916168"/>
+            <a:ext cx="3291840" cy="365760"/>
+          </a:xfrm>
+          <a:prstGeom prst="rect">
+            <a:avLst/>
+          </a:prstGeom>
+          <a:noFill/>
+        </p:spPr>
+        <p:txBody>
+          <a:bodyPr wrap="square" anchor="ctr" lIns="45720" rIns="45720">
+            <a:spAutoFit/>
+          </a:bodyPr>
+          <a:lstStyle/>
+          <a:p>
+            <a:pPr algn="l">
+              <a:spcAft>
+                <a:spcPts val="400"/>
+              </a:spcAft>
+            </a:pPr>
+            <a:r>
+              <a:rPr sz="1200" b="1" i="0">
+                <a:solidFill>
+                  <a:srgbClr val="1F2937"/>
+                </a:solidFill>
+                <a:latin typeface="Calibri"/>
+              </a:rPr>
+              <a:t>Bedrock Nova 2 Lite (4 workers)</a:t>
+            </a:r>
+          </a:p>
+        </p:txBody>
+      </p:sp>
+      <p:sp>
+        <p:nvSpPr>
+          <p:cNvPr id="13" name="Rectangle 12"/>
+          <p:cNvSpPr/>
+          <p:nvPr/>
+        </p:nvSpPr>
+        <p:spPr>
+          <a:xfrm>
+            <a:off x="3794760" y="5980176"/>
+            <a:ext cx="240729" cy="237744"/>
+          </a:xfrm>
+          <a:prstGeom prst="rect">
+            <a:avLst/>
+          </a:prstGeom>
+          <a:solidFill>
+            <a:srgbClr val="14B8A6"/>
+          </a:solidFill>
+          <a:ln>
+            <a:noFill/>
+          </a:ln>
+          <a:effectLst/>
+        </p:spPr>
+        <p:style>
+          <a:lnRef idx="1">
+            <a:schemeClr val="accent1"/>
+          </a:lnRef>
+          <a:fillRef idx="3">
+            <a:schemeClr val="accent1"/>
+          </a:fillRef>
+          <a:effectRef idx="2">
+            <a:schemeClr val="accent1"/>
+          </a:effectRef>
+          <a:fontRef idx="minor">
+            <a:schemeClr val="lt1"/>
+          </a:fontRef>
+        </p:style>
+        <p:txBody>
+          <a:bodyPr rtlCol="0" anchor="ctr"/>
+          <a:lstStyle/>
+          <a:p/>
+        </p:txBody>
+      </p:sp>
+      <p:sp>
+        <p:nvSpPr>
+          <p:cNvPr id="14" name="TextBox 13"/>
+          <p:cNvSpPr txBox="1"/>
+          <p:nvPr/>
+        </p:nvSpPr>
+        <p:spPr>
+          <a:xfrm>
+            <a:off x="4081209" y="5916168"/>
+            <a:ext cx="914400" cy="365760"/>
+          </a:xfrm>
+          <a:prstGeom prst="rect">
+            <a:avLst/>
+          </a:prstGeom>
+          <a:noFill/>
+        </p:spPr>
+        <p:txBody>
+          <a:bodyPr wrap="square" anchor="ctr" lIns="45720" rIns="45720">
+            <a:spAutoFit/>
+          </a:bodyPr>
+          <a:lstStyle/>
+          <a:p>
+            <a:pPr algn="l">
+              <a:spcAft>
+                <a:spcPts val="400"/>
+              </a:spcAft>
+            </a:pPr>
+            <a:r>
+              <a:rPr sz="1200" b="1" i="0">
+                <a:solidFill>
+                  <a:srgbClr val="0F1F3D"/>
+                </a:solidFill>
+                <a:latin typeface="Calibri"/>
+              </a:rPr>
+              <a:t>8.6 s</a:t>
+            </a:r>
+          </a:p>
+        </p:txBody>
+      </p:sp>
+      <p:sp>
+        <p:nvSpPr>
+          <p:cNvPr id="15" name="Rounded Rectangle 14"/>
           <p:cNvSpPr/>
           <p:nvPr/>
         </p:nvSpPr>
@@ -6029,7 +6340,7 @@
       </p:sp>
       <p:sp>
         <p:nvSpPr>
-          <p:cNvPr id="10" name="TextBox 9"/>
+          <p:cNvPr id="16" name="TextBox 15"/>
           <p:cNvSpPr txBox="1"/>
           <p:nvPr/>
         </p:nvSpPr>
@@ -6068,7 +6379,7 @@
       </p:sp>
       <p:sp>
         <p:nvSpPr>
-          <p:cNvPr id="11" name="TextBox 10"/>
+          <p:cNvPr id="17" name="TextBox 16"/>
           <p:cNvSpPr txBox="1"/>
           <p:nvPr/>
         </p:nvSpPr>
@@ -6107,7 +6418,7 @@
       </p:sp>
       <p:sp>
         <p:nvSpPr>
-          <p:cNvPr id="12" name="Rounded Rectangle 11"/>
+          <p:cNvPr id="18" name="Rounded Rectangle 17"/>
           <p:cNvSpPr/>
           <p:nvPr/>
         </p:nvSpPr>
@@ -6151,7 +6462,7 @@
       </p:sp>
       <p:sp>
         <p:nvSpPr>
-          <p:cNvPr id="13" name="TextBox 12"/>
+          <p:cNvPr id="19" name="TextBox 18"/>
           <p:cNvSpPr txBox="1"/>
           <p:nvPr/>
         </p:nvSpPr>
@@ -6190,7 +6501,7 @@
       </p:sp>
       <p:sp>
         <p:nvSpPr>
-          <p:cNvPr id="14" name="TextBox 13"/>
+          <p:cNvPr id="20" name="TextBox 19"/>
           <p:cNvSpPr txBox="1"/>
           <p:nvPr/>
         </p:nvSpPr>
@@ -6229,7 +6540,7 @@
       </p:sp>
       <p:sp>
         <p:nvSpPr>
-          <p:cNvPr id="15" name="Rounded Rectangle 14"/>
+          <p:cNvPr id="21" name="Rounded Rectangle 20"/>
           <p:cNvSpPr/>
           <p:nvPr/>
         </p:nvSpPr>
@@ -6273,7 +6584,7 @@
       </p:sp>
       <p:sp>
         <p:nvSpPr>
-          <p:cNvPr id="16" name="TextBox 15"/>
+          <p:cNvPr id="22" name="TextBox 21"/>
           <p:cNvSpPr txBox="1"/>
           <p:nvPr/>
         </p:nvSpPr>
@@ -6312,7 +6623,7 @@
       </p:sp>
       <p:sp>
         <p:nvSpPr>
-          <p:cNvPr id="17" name="TextBox 16"/>
+          <p:cNvPr id="23" name="TextBox 22"/>
           <p:cNvSpPr txBox="1"/>
           <p:nvPr/>
         </p:nvSpPr>
@@ -6344,14 +6655,14 @@
                 </a:solidFill>
                 <a:latin typeface="Calibri"/>
               </a:rPr>
-              <a:t>total, 3 workers</a:t>
-            </a:r>
-          </a:p>
-        </p:txBody>
-      </p:sp>
-      <p:sp>
-        <p:nvSpPr>
-          <p:cNvPr id="18" name="Rounded Rectangle 17"/>
+              <a:t>total, 3 workers (local Ollama)</a:t>
+            </a:r>
+          </a:p>
+        </p:txBody>
+      </p:sp>
+      <p:sp>
+        <p:nvSpPr>
+          <p:cNvPr id="24" name="Rounded Rectangle 23"/>
           <p:cNvSpPr/>
           <p:nvPr/>
         </p:nvSpPr>
@@ -6395,7 +6706,7 @@
       </p:sp>
       <p:sp>
         <p:nvSpPr>
-          <p:cNvPr id="19" name="TextBox 18"/>
+          <p:cNvPr id="25" name="TextBox 24"/>
           <p:cNvSpPr txBox="1"/>
           <p:nvPr/>
         </p:nvSpPr>
@@ -6427,14 +6738,14 @@
                 </a:solidFill>
                 <a:latin typeface="Calibri"/>
               </a:rPr>
-              <a:t>28</a:t>
-            </a:r>
-          </a:p>
-        </p:txBody>
-      </p:sp>
-      <p:sp>
-        <p:nvSpPr>
-          <p:cNvPr id="20" name="TextBox 19"/>
+              <a:t>~15×</a:t>
+            </a:r>
+          </a:p>
+        </p:txBody>
+      </p:sp>
+      <p:sp>
+        <p:nvSpPr>
+          <p:cNvPr id="26" name="TextBox 25"/>
           <p:cNvSpPr txBox="1"/>
           <p:nvPr/>
         </p:nvSpPr>
@@ -6466,7 +6777,7 @@
                 </a:solidFill>
                 <a:latin typeface="Calibri"/>
               </a:rPr>
-              <a:t>pytest tests passing</a:t>
+              <a:t>faster on AWS Bedrock</a:t>
             </a:r>
           </a:p>
         </p:txBody>
@@ -6693,7 +7004,7 @@
                 </a:solidFill>
                 <a:latin typeface="Calibri"/>
               </a:rPr>
-              <a:t>11 / 12</a:t>
+              <a:t>11 / 13</a:t>
             </a:r>
           </a:p>
         </p:txBody>
@@ -6746,7 +7057,7 @@
         <p:spPr>
           <a:xfrm>
             <a:off x="457200" y="1737360"/>
-            <a:ext cx="5303520" cy="621792"/>
+            <a:ext cx="5303520" cy="548640"/>
           </a:xfrm>
           <a:prstGeom prst="roundRect">
             <a:avLst>
@@ -6790,7 +7101,7 @@
         <p:spPr>
           <a:xfrm>
             <a:off x="594360" y="1737360"/>
-            <a:ext cx="2651760" cy="621792"/>
+            <a:ext cx="2651760" cy="548640"/>
           </a:xfrm>
           <a:prstGeom prst="rect">
             <a:avLst/>
@@ -6829,7 +7140,7 @@
         <p:spPr>
           <a:xfrm>
             <a:off x="3246120" y="1737360"/>
-            <a:ext cx="2468880" cy="621792"/>
+            <a:ext cx="2468880" cy="548640"/>
           </a:xfrm>
           <a:prstGeom prst="rect">
             <a:avLst/>
@@ -6867,8 +7178,8 @@
         </p:nvSpPr>
         <p:spPr>
           <a:xfrm>
-            <a:off x="457200" y="2468880"/>
-            <a:ext cx="5303520" cy="621792"/>
+            <a:off x="457200" y="2377439"/>
+            <a:ext cx="5303520" cy="548640"/>
           </a:xfrm>
           <a:prstGeom prst="roundRect">
             <a:avLst>
@@ -6911,8 +7222,8 @@
         </p:nvSpPr>
         <p:spPr>
           <a:xfrm>
-            <a:off x="594360" y="2468880"/>
-            <a:ext cx="2651760" cy="621792"/>
+            <a:off x="594360" y="2377439"/>
+            <a:ext cx="2651760" cy="548640"/>
           </a:xfrm>
           <a:prstGeom prst="rect">
             <a:avLst/>
@@ -6950,8 +7261,8 @@
         </p:nvSpPr>
         <p:spPr>
           <a:xfrm>
-            <a:off x="3246120" y="2468880"/>
-            <a:ext cx="2468880" cy="621792"/>
+            <a:off x="3246120" y="2377439"/>
+            <a:ext cx="2468880" cy="548640"/>
           </a:xfrm>
           <a:prstGeom prst="rect">
             <a:avLst/>
@@ -6989,8 +7300,8 @@
         </p:nvSpPr>
         <p:spPr>
           <a:xfrm>
-            <a:off x="457200" y="3200400"/>
-            <a:ext cx="5303520" cy="621792"/>
+            <a:off x="457200" y="3017520"/>
+            <a:ext cx="5303520" cy="548640"/>
           </a:xfrm>
           <a:prstGeom prst="roundRect">
             <a:avLst>
@@ -7033,8 +7344,8 @@
         </p:nvSpPr>
         <p:spPr>
           <a:xfrm>
-            <a:off x="594360" y="3200400"/>
-            <a:ext cx="2651760" cy="621792"/>
+            <a:off x="594360" y="3017520"/>
+            <a:ext cx="2651760" cy="548640"/>
           </a:xfrm>
           <a:prstGeom prst="rect">
             <a:avLst/>
@@ -7072,8 +7383,8 @@
         </p:nvSpPr>
         <p:spPr>
           <a:xfrm>
-            <a:off x="3246120" y="3200400"/>
-            <a:ext cx="2468880" cy="621792"/>
+            <a:off x="3246120" y="3017520"/>
+            <a:ext cx="2468880" cy="548640"/>
           </a:xfrm>
           <a:prstGeom prst="rect">
             <a:avLst/>
@@ -7111,8 +7422,8 @@
         </p:nvSpPr>
         <p:spPr>
           <a:xfrm>
-            <a:off x="457200" y="3931920"/>
-            <a:ext cx="5303520" cy="621792"/>
+            <a:off x="457200" y="3657599"/>
+            <a:ext cx="5303520" cy="548640"/>
           </a:xfrm>
           <a:prstGeom prst="roundRect">
             <a:avLst>
@@ -7155,8 +7466,8 @@
         </p:nvSpPr>
         <p:spPr>
           <a:xfrm>
-            <a:off x="594360" y="3931920"/>
-            <a:ext cx="2651760" cy="621792"/>
+            <a:off x="594360" y="3657599"/>
+            <a:ext cx="2651760" cy="548640"/>
           </a:xfrm>
           <a:prstGeom prst="rect">
             <a:avLst/>
@@ -7194,8 +7505,8 @@
         </p:nvSpPr>
         <p:spPr>
           <a:xfrm>
-            <a:off x="3246120" y="3931920"/>
-            <a:ext cx="2468880" cy="621792"/>
+            <a:off x="3246120" y="3657599"/>
+            <a:ext cx="2468880" cy="548640"/>
           </a:xfrm>
           <a:prstGeom prst="rect">
             <a:avLst/>
@@ -7233,8 +7544,8 @@
         </p:nvSpPr>
         <p:spPr>
           <a:xfrm>
-            <a:off x="457200" y="4663440"/>
-            <a:ext cx="5303520" cy="621792"/>
+            <a:off x="457200" y="4297679"/>
+            <a:ext cx="5303520" cy="548640"/>
           </a:xfrm>
           <a:prstGeom prst="roundRect">
             <a:avLst>
@@ -7277,8 +7588,8 @@
         </p:nvSpPr>
         <p:spPr>
           <a:xfrm>
-            <a:off x="594360" y="4663440"/>
-            <a:ext cx="2651760" cy="621792"/>
+            <a:off x="594360" y="4297679"/>
+            <a:ext cx="2651760" cy="548640"/>
           </a:xfrm>
           <a:prstGeom prst="rect">
             <a:avLst/>
@@ -7303,7 +7614,7 @@
                 </a:solidFill>
                 <a:latin typeface="Calibri"/>
               </a:rPr>
-              <a:t>OpenAI • Gemini • Ollama</a:t>
+              <a:t>LLM providers</a:t>
             </a:r>
           </a:p>
         </p:txBody>
@@ -7316,8 +7627,8 @@
         </p:nvSpPr>
         <p:spPr>
           <a:xfrm>
-            <a:off x="3246120" y="4663440"/>
-            <a:ext cx="2468880" cy="621792"/>
+            <a:off x="3246120" y="4297679"/>
+            <a:ext cx="2468880" cy="548640"/>
           </a:xfrm>
           <a:prstGeom prst="rect">
             <a:avLst/>
@@ -7342,7 +7653,7 @@
                 </a:solidFill>
                 <a:latin typeface="Calibri"/>
               </a:rPr>
-              <a:t>swappable LLM providers</a:t>
+              <a:t>OpenAI, Gemini, Ollama, AWS Bedrock</a:t>
             </a:r>
           </a:p>
         </p:txBody>
@@ -7355,8 +7666,8 @@
         </p:nvSpPr>
         <p:spPr>
           <a:xfrm>
-            <a:off x="457200" y="5394960"/>
-            <a:ext cx="5303520" cy="621792"/>
+            <a:off x="457200" y="4937760"/>
+            <a:ext cx="5303520" cy="548640"/>
           </a:xfrm>
           <a:prstGeom prst="roundRect">
             <a:avLst>
@@ -7399,8 +7710,8 @@
         </p:nvSpPr>
         <p:spPr>
           <a:xfrm>
-            <a:off x="594360" y="5394960"/>
-            <a:ext cx="2651760" cy="621792"/>
+            <a:off x="594360" y="4937760"/>
+            <a:ext cx="2651760" cy="548640"/>
           </a:xfrm>
           <a:prstGeom prst="rect">
             <a:avLst/>
@@ -7425,7 +7736,7 @@
                 </a:solidFill>
                 <a:latin typeface="Calibri"/>
               </a:rPr>
-              <a:t>pytest</a:t>
+              <a:t>Streamlit • Docker</a:t>
             </a:r>
           </a:p>
         </p:txBody>
@@ -7438,8 +7749,8 @@
         </p:nvSpPr>
         <p:spPr>
           <a:xfrm>
-            <a:off x="3246120" y="5394960"/>
-            <a:ext cx="2468880" cy="621792"/>
+            <a:off x="3246120" y="4937760"/>
+            <a:ext cx="2468880" cy="548640"/>
           </a:xfrm>
           <a:prstGeom prst="rect">
             <a:avLst/>
@@ -7464,14 +7775,136 @@
                 </a:solidFill>
                 <a:latin typeface="Calibri"/>
               </a:rPr>
-              <a:t>28 offline tests (fake LLM)</a:t>
-            </a:r>
-          </a:p>
-        </p:txBody>
-      </p:sp>
-      <p:sp>
-        <p:nvSpPr>
-          <p:cNvPr id="26" name="TextBox 25"/>
+              <a:t>web UI, container on AWS EC2</a:t>
+            </a:r>
+          </a:p>
+        </p:txBody>
+      </p:sp>
+      <p:sp>
+        <p:nvSpPr>
+          <p:cNvPr id="26" name="Rounded Rectangle 25"/>
+          <p:cNvSpPr/>
+          <p:nvPr/>
+        </p:nvSpPr>
+        <p:spPr>
+          <a:xfrm>
+            <a:off x="457200" y="5577840"/>
+            <a:ext cx="5303520" cy="548640"/>
+          </a:xfrm>
+          <a:prstGeom prst="roundRect">
+            <a:avLst>
+              <a:gd name="adj" fmla="val 8000"/>
+            </a:avLst>
+          </a:prstGeom>
+          <a:solidFill>
+            <a:srgbClr val="F1F5F9"/>
+          </a:solidFill>
+          <a:ln>
+            <a:noFill/>
+          </a:ln>
+          <a:effectLst/>
+        </p:spPr>
+        <p:style>
+          <a:lnRef idx="1">
+            <a:schemeClr val="accent1"/>
+          </a:lnRef>
+          <a:fillRef idx="3">
+            <a:schemeClr val="accent1"/>
+          </a:fillRef>
+          <a:effectRef idx="2">
+            <a:schemeClr val="accent1"/>
+          </a:effectRef>
+          <a:fontRef idx="minor">
+            <a:schemeClr val="lt1"/>
+          </a:fontRef>
+        </p:style>
+        <p:txBody>
+          <a:bodyPr rtlCol="0" anchor="ctr"/>
+          <a:lstStyle/>
+          <a:p/>
+        </p:txBody>
+      </p:sp>
+      <p:sp>
+        <p:nvSpPr>
+          <p:cNvPr id="27" name="TextBox 26"/>
+          <p:cNvSpPr txBox="1"/>
+          <p:nvPr/>
+        </p:nvSpPr>
+        <p:spPr>
+          <a:xfrm>
+            <a:off x="594360" y="5577840"/>
+            <a:ext cx="2651760" cy="548640"/>
+          </a:xfrm>
+          <a:prstGeom prst="rect">
+            <a:avLst/>
+          </a:prstGeom>
+          <a:noFill/>
+        </p:spPr>
+        <p:txBody>
+          <a:bodyPr wrap="square" anchor="ctr" lIns="45720" rIns="45720">
+            <a:spAutoFit/>
+          </a:bodyPr>
+          <a:lstStyle/>
+          <a:p>
+            <a:pPr algn="l">
+              <a:spcAft>
+                <a:spcPts val="400"/>
+              </a:spcAft>
+            </a:pPr>
+            <a:r>
+              <a:rPr sz="1600" b="1" i="0">
+                <a:solidFill>
+                  <a:srgbClr val="0F1F3D"/>
+                </a:solidFill>
+                <a:latin typeface="Calibri"/>
+              </a:rPr>
+              <a:t>pytest</a:t>
+            </a:r>
+          </a:p>
+        </p:txBody>
+      </p:sp>
+      <p:sp>
+        <p:nvSpPr>
+          <p:cNvPr id="28" name="TextBox 27"/>
+          <p:cNvSpPr txBox="1"/>
+          <p:nvPr/>
+        </p:nvSpPr>
+        <p:spPr>
+          <a:xfrm>
+            <a:off x="3246120" y="5577840"/>
+            <a:ext cx="2468880" cy="548640"/>
+          </a:xfrm>
+          <a:prstGeom prst="rect">
+            <a:avLst/>
+          </a:prstGeom>
+          <a:noFill/>
+        </p:spPr>
+        <p:txBody>
+          <a:bodyPr wrap="square" anchor="ctr" lIns="45720" rIns="45720">
+            <a:spAutoFit/>
+          </a:bodyPr>
+          <a:lstStyle/>
+          <a:p>
+            <a:pPr algn="l">
+              <a:spcAft>
+                <a:spcPts val="400"/>
+              </a:spcAft>
+            </a:pPr>
+            <a:r>
+              <a:rPr sz="1400" b="0" i="0">
+                <a:solidFill>
+                  <a:srgbClr val="1F2937"/>
+                </a:solidFill>
+                <a:latin typeface="Calibri"/>
+              </a:rPr>
+              <a:t>offline tests (fake LLM)</a:t>
+            </a:r>
+          </a:p>
+        </p:txBody>
+      </p:sp>
+      <p:sp>
+        <p:nvSpPr>
+          <p:cNvPr id="29" name="TextBox 28"/>
           <p:cNvSpPr txBox="1"/>
           <p:nvPr/>
         </p:nvSpPr>
@@ -7510,7 +7943,7 @@
       </p:sp>
       <p:sp>
         <p:nvSpPr>
-          <p:cNvPr id="27" name="TextBox 26"/>
+          <p:cNvPr id="30" name="TextBox 29"/>
           <p:cNvSpPr txBox="1"/>
           <p:nvPr/>
         </p:nvSpPr>
@@ -7594,7 +8027,7 @@
                 </a:solidFill>
                 <a:latin typeface="Calibri"/>
               </a:rPr>
-              <a:t>get_llm() lazily imports only the chosen SDK; runs fully local with Ollama</a:t>
+              <a:t>get_llm() lazily imports only the chosen SDK; runs fully local with Ollama or on AWS Bedrock</a:t>
             </a:r>
           </a:p>
           <a:p>
@@ -7845,7 +8278,7 @@
                 </a:solidFill>
                 <a:latin typeface="Calibri"/>
               </a:rPr>
-              <a:t>Limitations &amp; Future Work</a:t>
+              <a:t>Web UI &amp; Cloud Deployment (AWS)</a:t>
             </a:r>
           </a:p>
         </p:txBody>
@@ -7923,21 +8356,220 @@
                 </a:solidFill>
                 <a:latin typeface="Calibri"/>
               </a:rPr>
-              <a:t>12 / 12</a:t>
-            </a:r>
-          </a:p>
-        </p:txBody>
-      </p:sp>
-      <p:sp>
-        <p:nvSpPr>
-          <p:cNvPr id="7" name="TextBox 6"/>
+              <a:t>12 / 13</a:t>
+            </a:r>
+          </a:p>
+        </p:txBody>
+      </p:sp>
+      <p:sp>
+        <p:nvSpPr>
+          <p:cNvPr id="7" name="Rounded Rectangle 6"/>
+          <p:cNvSpPr/>
+          <p:nvPr/>
+        </p:nvSpPr>
+        <p:spPr>
+          <a:xfrm>
+            <a:off x="365760" y="2103120"/>
+            <a:ext cx="1645920" cy="1188720"/>
+          </a:xfrm>
+          <a:prstGeom prst="roundRect">
+            <a:avLst>
+              <a:gd name="adj" fmla="val 8000"/>
+            </a:avLst>
+          </a:prstGeom>
+          <a:solidFill>
+            <a:srgbClr val="F1F5F9"/>
+          </a:solidFill>
+          <a:ln w="12700">
+            <a:solidFill>
+              <a:srgbClr val="CBD5E1"/>
+            </a:solidFill>
+          </a:ln>
+          <a:effectLst/>
+        </p:spPr>
+        <p:style>
+          <a:lnRef idx="1">
+            <a:schemeClr val="accent1"/>
+          </a:lnRef>
+          <a:fillRef idx="3">
+            <a:schemeClr val="accent1"/>
+          </a:fillRef>
+          <a:effectRef idx="2">
+            <a:schemeClr val="accent1"/>
+          </a:effectRef>
+          <a:fontRef idx="minor">
+            <a:schemeClr val="lt1"/>
+          </a:fontRef>
+        </p:style>
+        <p:txBody>
+          <a:bodyPr rtlCol="0" anchor="ctr" wrap="square" tIns="54864" bIns="54864"/>
+          <a:lstStyle/>
+          <a:p>
+            <a:pPr algn="ctr">
+              <a:spcAft>
+                <a:spcPts val="300"/>
+              </a:spcAft>
+            </a:pPr>
+            <a:r>
+              <a:rPr sz="1700" b="1" i="0">
+                <a:solidFill>
+                  <a:srgbClr val="0F1F3D"/>
+                </a:solidFill>
+                <a:latin typeface="Calibri"/>
+              </a:rPr>
+              <a:t>User</a:t>
+            </a:r>
+          </a:p>
+          <a:p>
+            <a:pPr algn="ctr">
+              <a:spcAft>
+                <a:spcPts val="200"/>
+              </a:spcAft>
+            </a:pPr>
+            <a:r>
+              <a:rPr sz="1300" b="0" i="0">
+                <a:solidFill>
+                  <a:srgbClr val="1F2937"/>
+                </a:solidFill>
+                <a:latin typeface="Calibri"/>
+              </a:rPr>
+              <a:t>web browser</a:t>
+            </a:r>
+          </a:p>
+        </p:txBody>
+      </p:sp>
+      <p:sp>
+        <p:nvSpPr>
+          <p:cNvPr id="8" name="Rounded Rectangle 7"/>
+          <p:cNvSpPr/>
+          <p:nvPr/>
+        </p:nvSpPr>
+        <p:spPr>
+          <a:xfrm>
+            <a:off x="365760" y="3977639"/>
+            <a:ext cx="1645920" cy="1188720"/>
+          </a:xfrm>
+          <a:prstGeom prst="roundRect">
+            <a:avLst>
+              <a:gd name="adj" fmla="val 8000"/>
+            </a:avLst>
+          </a:prstGeom>
+          <a:solidFill>
+            <a:srgbClr val="F1F5F9"/>
+          </a:solidFill>
+          <a:ln w="12700">
+            <a:solidFill>
+              <a:srgbClr val="CBD5E1"/>
+            </a:solidFill>
+          </a:ln>
+          <a:effectLst/>
+        </p:spPr>
+        <p:style>
+          <a:lnRef idx="1">
+            <a:schemeClr val="accent1"/>
+          </a:lnRef>
+          <a:fillRef idx="3">
+            <a:schemeClr val="accent1"/>
+          </a:fillRef>
+          <a:effectRef idx="2">
+            <a:schemeClr val="accent1"/>
+          </a:effectRef>
+          <a:fontRef idx="minor">
+            <a:schemeClr val="lt1"/>
+          </a:fontRef>
+        </p:style>
+        <p:txBody>
+          <a:bodyPr rtlCol="0" anchor="ctr" wrap="square" tIns="54864" bIns="54864"/>
+          <a:lstStyle/>
+          <a:p>
+            <a:pPr algn="ctr">
+              <a:spcAft>
+                <a:spcPts val="300"/>
+              </a:spcAft>
+            </a:pPr>
+            <a:r>
+              <a:rPr sz="1700" b="1" i="0">
+                <a:solidFill>
+                  <a:srgbClr val="0F1F3D"/>
+                </a:solidFill>
+                <a:latin typeface="Calibri"/>
+              </a:rPr>
+              <a:t>GitHub</a:t>
+            </a:r>
+          </a:p>
+          <a:p>
+            <a:pPr algn="ctr">
+              <a:spcAft>
+                <a:spcPts val="200"/>
+              </a:spcAft>
+            </a:pPr>
+            <a:r>
+              <a:rPr sz="1300" b="0" i="0">
+                <a:solidFill>
+                  <a:srgbClr val="1F2937"/>
+                </a:solidFill>
+                <a:latin typeface="Calibri"/>
+              </a:rPr>
+              <a:t>public repo</a:t>
+            </a:r>
+          </a:p>
+        </p:txBody>
+      </p:sp>
+      <p:sp>
+        <p:nvSpPr>
+          <p:cNvPr id="9" name="Rounded Rectangle 8"/>
+          <p:cNvSpPr/>
+          <p:nvPr/>
+        </p:nvSpPr>
+        <p:spPr>
+          <a:xfrm>
+            <a:off x="2697480" y="1234440"/>
+            <a:ext cx="5943600" cy="4114800"/>
+          </a:xfrm>
+          <a:prstGeom prst="roundRect">
+            <a:avLst>
+              <a:gd name="adj" fmla="val 8000"/>
+            </a:avLst>
+          </a:prstGeom>
+          <a:noFill/>
+          <a:ln w="19050">
+            <a:solidFill>
+              <a:srgbClr val="F59E0B"/>
+            </a:solidFill>
+            <a:prstDash val="dash"/>
+          </a:ln>
+          <a:effectLst/>
+        </p:spPr>
+        <p:style>
+          <a:lnRef idx="1">
+            <a:schemeClr val="accent1"/>
+          </a:lnRef>
+          <a:fillRef idx="3">
+            <a:schemeClr val="accent1"/>
+          </a:fillRef>
+          <a:effectRef idx="2">
+            <a:schemeClr val="accent1"/>
+          </a:effectRef>
+          <a:fontRef idx="minor">
+            <a:schemeClr val="lt1"/>
+          </a:fontRef>
+        </p:style>
+        <p:txBody>
+          <a:bodyPr rtlCol="0" anchor="ctr"/>
+          <a:lstStyle/>
+          <a:p/>
+        </p:txBody>
+      </p:sp>
+      <p:sp>
+        <p:nvSpPr>
+          <p:cNvPr id="10" name="TextBox 9"/>
           <p:cNvSpPr txBox="1"/>
           <p:nvPr/>
         </p:nvSpPr>
         <p:spPr>
           <a:xfrm>
-            <a:off x="457200" y="1188720"/>
-            <a:ext cx="5394960" cy="502920"/>
+            <a:off x="2788920" y="1261872"/>
+            <a:ext cx="5760720" cy="365760"/>
           </a:xfrm>
           <a:prstGeom prst="rect">
             <a:avLst/>
@@ -7950,6 +8582,1326 @@
           </a:bodyPr>
           <a:lstStyle/>
           <a:p>
+            <a:pPr algn="ctr">
+              <a:spcAft>
+                <a:spcPts val="400"/>
+              </a:spcAft>
+            </a:pPr>
+            <a:r>
+              <a:rPr sz="1300" b="1" i="0">
+                <a:solidFill>
+                  <a:srgbClr val="F59E0B"/>
+                </a:solidFill>
+                <a:latin typeface="Calibri"/>
+              </a:rPr>
+              <a:t>EC2 t4g.small  •  Amazon Linux 2023 (arm64)  •  ap-south-1</a:t>
+            </a:r>
+          </a:p>
+        </p:txBody>
+      </p:sp>
+      <p:sp>
+        <p:nvSpPr>
+          <p:cNvPr id="11" name="Rounded Rectangle 10"/>
+          <p:cNvSpPr/>
+          <p:nvPr/>
+        </p:nvSpPr>
+        <p:spPr>
+          <a:xfrm>
+            <a:off x="2880360" y="1691640"/>
+            <a:ext cx="5577840" cy="1783080"/>
+          </a:xfrm>
+          <a:prstGeom prst="roundRect">
+            <a:avLst>
+              <a:gd name="adj" fmla="val 8000"/>
+            </a:avLst>
+          </a:prstGeom>
+          <a:solidFill>
+            <a:srgbClr val="E6F7F5"/>
+          </a:solidFill>
+          <a:ln w="12700">
+            <a:solidFill>
+              <a:srgbClr val="14B8A6"/>
+            </a:solidFill>
+          </a:ln>
+          <a:effectLst/>
+        </p:spPr>
+        <p:style>
+          <a:lnRef idx="1">
+            <a:schemeClr val="accent1"/>
+          </a:lnRef>
+          <a:fillRef idx="3">
+            <a:schemeClr val="accent1"/>
+          </a:fillRef>
+          <a:effectRef idx="2">
+            <a:schemeClr val="accent1"/>
+          </a:effectRef>
+          <a:fontRef idx="minor">
+            <a:schemeClr val="lt1"/>
+          </a:fontRef>
+        </p:style>
+        <p:txBody>
+          <a:bodyPr rtlCol="0" anchor="ctr"/>
+          <a:lstStyle/>
+          <a:p/>
+        </p:txBody>
+      </p:sp>
+      <p:sp>
+        <p:nvSpPr>
+          <p:cNvPr id="12" name="TextBox 11"/>
+          <p:cNvSpPr txBox="1"/>
+          <p:nvPr/>
+        </p:nvSpPr>
+        <p:spPr>
+          <a:xfrm>
+            <a:off x="2971800" y="1719072"/>
+            <a:ext cx="5394960" cy="320040"/>
+          </a:xfrm>
+          <a:prstGeom prst="rect">
+            <a:avLst/>
+          </a:prstGeom>
+          <a:noFill/>
+        </p:spPr>
+        <p:txBody>
+          <a:bodyPr wrap="square" anchor="t" lIns="45720" rIns="45720">
+            <a:spAutoFit/>
+          </a:bodyPr>
+          <a:lstStyle/>
+          <a:p>
+            <a:pPr algn="ctr">
+              <a:spcAft>
+                <a:spcPts val="400"/>
+              </a:spcAft>
+            </a:pPr>
+            <a:r>
+              <a:rPr sz="1200" b="1" i="0">
+                <a:solidFill>
+                  <a:srgbClr val="14B8A6"/>
+                </a:solidFill>
+                <a:latin typeface="Calibri"/>
+              </a:rPr>
+              <a:t>Docker container  (python:3.11-slim, non-root)</a:t>
+            </a:r>
+          </a:p>
+        </p:txBody>
+      </p:sp>
+      <p:sp>
+        <p:nvSpPr>
+          <p:cNvPr id="13" name="Rounded Rectangle 12"/>
+          <p:cNvSpPr/>
+          <p:nvPr/>
+        </p:nvSpPr>
+        <p:spPr>
+          <a:xfrm>
+            <a:off x="3063240" y="2148840"/>
+            <a:ext cx="2286000" cy="1143000"/>
+          </a:xfrm>
+          <a:prstGeom prst="roundRect">
+            <a:avLst>
+              <a:gd name="adj" fmla="val 8000"/>
+            </a:avLst>
+          </a:prstGeom>
+          <a:solidFill>
+            <a:srgbClr val="FFFFFF"/>
+          </a:solidFill>
+          <a:ln w="12700">
+            <a:solidFill>
+              <a:srgbClr val="1C335E"/>
+            </a:solidFill>
+          </a:ln>
+          <a:effectLst/>
+        </p:spPr>
+        <p:style>
+          <a:lnRef idx="1">
+            <a:schemeClr val="accent1"/>
+          </a:lnRef>
+          <a:fillRef idx="3">
+            <a:schemeClr val="accent1"/>
+          </a:fillRef>
+          <a:effectRef idx="2">
+            <a:schemeClr val="accent1"/>
+          </a:effectRef>
+          <a:fontRef idx="minor">
+            <a:schemeClr val="lt1"/>
+          </a:fontRef>
+        </p:style>
+        <p:txBody>
+          <a:bodyPr rtlCol="0" anchor="ctr" wrap="square" tIns="54864" bIns="54864"/>
+          <a:lstStyle/>
+          <a:p>
+            <a:pPr algn="ctr">
+              <a:spcAft>
+                <a:spcPts val="300"/>
+              </a:spcAft>
+            </a:pPr>
+            <a:r>
+              <a:rPr sz="1600" b="1" i="0">
+                <a:solidFill>
+                  <a:srgbClr val="0F1F3D"/>
+                </a:solidFill>
+                <a:latin typeface="Calibri"/>
+              </a:rPr>
+              <a:t>Streamlit UI</a:t>
+            </a:r>
+          </a:p>
+          <a:p>
+            <a:pPr algn="ctr">
+              <a:spcAft>
+                <a:spcPts val="200"/>
+              </a:spcAft>
+            </a:pPr>
+            <a:r>
+              <a:rPr sz="1300" b="0" i="0">
+                <a:solidFill>
+                  <a:srgbClr val="1F2937"/>
+                </a:solidFill>
+                <a:latin typeface="Calibri"/>
+              </a:rPr>
+              <a:t>app.py  •  :8501</a:t>
+            </a:r>
+          </a:p>
+        </p:txBody>
+      </p:sp>
+      <p:sp>
+        <p:nvSpPr>
+          <p:cNvPr id="14" name="Rounded Rectangle 13"/>
+          <p:cNvSpPr/>
+          <p:nvPr/>
+        </p:nvSpPr>
+        <p:spPr>
+          <a:xfrm>
+            <a:off x="5989320" y="2148840"/>
+            <a:ext cx="2286000" cy="1143000"/>
+          </a:xfrm>
+          <a:prstGeom prst="roundRect">
+            <a:avLst>
+              <a:gd name="adj" fmla="val 8000"/>
+            </a:avLst>
+          </a:prstGeom>
+          <a:solidFill>
+            <a:srgbClr val="FFFFFF"/>
+          </a:solidFill>
+          <a:ln w="12700">
+            <a:solidFill>
+              <a:srgbClr val="1C335E"/>
+            </a:solidFill>
+          </a:ln>
+          <a:effectLst/>
+        </p:spPr>
+        <p:style>
+          <a:lnRef idx="1">
+            <a:schemeClr val="accent1"/>
+          </a:lnRef>
+          <a:fillRef idx="3">
+            <a:schemeClr val="accent1"/>
+          </a:fillRef>
+          <a:effectRef idx="2">
+            <a:schemeClr val="accent1"/>
+          </a:effectRef>
+          <a:fontRef idx="minor">
+            <a:schemeClr val="lt1"/>
+          </a:fontRef>
+        </p:style>
+        <p:txBody>
+          <a:bodyPr rtlCol="0" anchor="ctr" wrap="square" tIns="54864" bIns="54864"/>
+          <a:lstStyle/>
+          <a:p>
+            <a:pPr algn="ctr">
+              <a:spcAft>
+                <a:spcPts val="300"/>
+              </a:spcAft>
+            </a:pPr>
+            <a:r>
+              <a:rPr sz="1600" b="1" i="0">
+                <a:solidFill>
+                  <a:srgbClr val="0F1F3D"/>
+                </a:solidFill>
+                <a:latin typeface="Calibri"/>
+              </a:rPr>
+              <a:t>Pipeline</a:t>
+            </a:r>
+          </a:p>
+          <a:p>
+            <a:pPr algn="ctr">
+              <a:spcAft>
+                <a:spcPts val="200"/>
+              </a:spcAft>
+            </a:pPr>
+            <a:r>
+              <a:rPr sz="1300" b="0" i="0">
+                <a:solidFill>
+                  <a:srgbClr val="1F2937"/>
+                </a:solidFill>
+                <a:latin typeface="Calibri"/>
+              </a:rPr>
+              <a:t>extract → email ‖ summary</a:t>
+            </a:r>
+          </a:p>
+        </p:txBody>
+      </p:sp>
+      <p:sp>
+        <p:nvSpPr>
+          <p:cNvPr id="15" name="Rounded Rectangle 14"/>
+          <p:cNvSpPr/>
+          <p:nvPr/>
+        </p:nvSpPr>
+        <p:spPr>
+          <a:xfrm>
+            <a:off x="2880360" y="3703320"/>
+            <a:ext cx="2743200" cy="1463040"/>
+          </a:xfrm>
+          <a:prstGeom prst="roundRect">
+            <a:avLst>
+              <a:gd name="adj" fmla="val 8000"/>
+            </a:avLst>
+          </a:prstGeom>
+          <a:solidFill>
+            <a:srgbClr val="FFFFFF"/>
+          </a:solidFill>
+          <a:ln w="12700">
+            <a:solidFill>
+              <a:srgbClr val="CBD5E1"/>
+            </a:solidFill>
+          </a:ln>
+          <a:effectLst/>
+        </p:spPr>
+        <p:style>
+          <a:lnRef idx="1">
+            <a:schemeClr val="accent1"/>
+          </a:lnRef>
+          <a:fillRef idx="3">
+            <a:schemeClr val="accent1"/>
+          </a:fillRef>
+          <a:effectRef idx="2">
+            <a:schemeClr val="accent1"/>
+          </a:effectRef>
+          <a:fontRef idx="minor">
+            <a:schemeClr val="lt1"/>
+          </a:fontRef>
+        </p:style>
+        <p:txBody>
+          <a:bodyPr rtlCol="0" anchor="ctr" wrap="square" tIns="54864" bIns="54864"/>
+          <a:lstStyle/>
+          <a:p>
+            <a:pPr algn="ctr">
+              <a:spcAft>
+                <a:spcPts val="300"/>
+              </a:spcAft>
+            </a:pPr>
+            <a:r>
+              <a:rPr sz="1400" b="1" i="0">
+                <a:solidFill>
+                  <a:srgbClr val="0F1F3D"/>
+                </a:solidFill>
+                <a:latin typeface="Calibri"/>
+              </a:rPr>
+              <a:t>user-data / redeploy.sh</a:t>
+            </a:r>
+          </a:p>
+          <a:p>
+            <a:pPr algn="ctr">
+              <a:spcAft>
+                <a:spcPts val="200"/>
+              </a:spcAft>
+            </a:pPr>
+            <a:r>
+              <a:rPr sz="1200" b="0" i="0">
+                <a:solidFill>
+                  <a:srgbClr val="1F2937"/>
+                </a:solidFill>
+                <a:latin typeface="Calibri"/>
+              </a:rPr>
+              <a:t>git clone / pull</a:t>
+            </a:r>
+          </a:p>
+          <a:p>
+            <a:pPr algn="ctr">
+              <a:spcAft>
+                <a:spcPts val="200"/>
+              </a:spcAft>
+            </a:pPr>
+            <a:r>
+              <a:rPr sz="1200" b="0" i="0">
+                <a:solidFill>
+                  <a:srgbClr val="1F2937"/>
+                </a:solidFill>
+                <a:latin typeface="Calibri"/>
+              </a:rPr>
+              <a:t>docker build</a:t>
+            </a:r>
+          </a:p>
+          <a:p>
+            <a:pPr algn="ctr">
+              <a:spcAft>
+                <a:spcPts val="200"/>
+              </a:spcAft>
+            </a:pPr>
+            <a:r>
+              <a:rPr sz="1200" b="0" i="0">
+                <a:solidFill>
+                  <a:srgbClr val="1F2937"/>
+                </a:solidFill>
+                <a:latin typeface="Calibri"/>
+              </a:rPr>
+              <a:t>docker run -p 80:8501</a:t>
+            </a:r>
+          </a:p>
+        </p:txBody>
+      </p:sp>
+      <p:sp>
+        <p:nvSpPr>
+          <p:cNvPr id="16" name="Rounded Rectangle 15"/>
+          <p:cNvSpPr/>
+          <p:nvPr/>
+        </p:nvSpPr>
+        <p:spPr>
+          <a:xfrm>
+            <a:off x="5852160" y="3703320"/>
+            <a:ext cx="2423160" cy="1463040"/>
+          </a:xfrm>
+          <a:prstGeom prst="roundRect">
+            <a:avLst>
+              <a:gd name="adj" fmla="val 8000"/>
+            </a:avLst>
+          </a:prstGeom>
+          <a:solidFill>
+            <a:srgbClr val="FFFFFF"/>
+          </a:solidFill>
+          <a:ln w="12700">
+            <a:solidFill>
+              <a:srgbClr val="F59E0B"/>
+            </a:solidFill>
+          </a:ln>
+          <a:effectLst/>
+        </p:spPr>
+        <p:style>
+          <a:lnRef idx="1">
+            <a:schemeClr val="accent1"/>
+          </a:lnRef>
+          <a:fillRef idx="3">
+            <a:schemeClr val="accent1"/>
+          </a:fillRef>
+          <a:effectRef idx="2">
+            <a:schemeClr val="accent1"/>
+          </a:effectRef>
+          <a:fontRef idx="minor">
+            <a:schemeClr val="lt1"/>
+          </a:fontRef>
+        </p:style>
+        <p:txBody>
+          <a:bodyPr rtlCol="0" anchor="ctr" wrap="square" tIns="54864" bIns="54864"/>
+          <a:lstStyle/>
+          <a:p>
+            <a:pPr algn="ctr">
+              <a:spcAft>
+                <a:spcPts val="300"/>
+              </a:spcAft>
+            </a:pPr>
+            <a:r>
+              <a:rPr sz="1400" b="1" i="0">
+                <a:solidFill>
+                  <a:srgbClr val="0F1F3D"/>
+                </a:solidFill>
+                <a:latin typeface="Calibri"/>
+              </a:rPr>
+              <a:t>IAM instance role</a:t>
+            </a:r>
+          </a:p>
+          <a:p>
+            <a:pPr algn="ctr">
+              <a:spcAft>
+                <a:spcPts val="200"/>
+              </a:spcAft>
+            </a:pPr>
+            <a:r>
+              <a:rPr sz="1200" b="0" i="0">
+                <a:solidFill>
+                  <a:srgbClr val="1F2937"/>
+                </a:solidFill>
+                <a:latin typeface="Calibri"/>
+              </a:rPr>
+              <a:t>bedrock:InvokeModel</a:t>
+            </a:r>
+          </a:p>
+          <a:p>
+            <a:pPr algn="ctr">
+              <a:spcAft>
+                <a:spcPts val="200"/>
+              </a:spcAft>
+            </a:pPr>
+            <a:r>
+              <a:rPr sz="1200" b="0" i="0">
+                <a:solidFill>
+                  <a:srgbClr val="1F2937"/>
+                </a:solidFill>
+                <a:latin typeface="Calibri"/>
+              </a:rPr>
+              <a:t>+ SSM managed</a:t>
+            </a:r>
+          </a:p>
+          <a:p>
+            <a:pPr algn="ctr">
+              <a:spcAft>
+                <a:spcPts val="200"/>
+              </a:spcAft>
+            </a:pPr>
+            <a:r>
+              <a:rPr sz="1200" b="0" i="0">
+                <a:solidFill>
+                  <a:srgbClr val="1F2937"/>
+                </a:solidFill>
+                <a:latin typeface="Calibri"/>
+              </a:rPr>
+              <a:t>no API keys on server</a:t>
+            </a:r>
+          </a:p>
+        </p:txBody>
+      </p:sp>
+      <p:sp>
+        <p:nvSpPr>
+          <p:cNvPr id="17" name="Rounded Rectangle 16"/>
+          <p:cNvSpPr/>
+          <p:nvPr/>
+        </p:nvSpPr>
+        <p:spPr>
+          <a:xfrm>
+            <a:off x="9189720" y="1920240"/>
+            <a:ext cx="2606040" cy="1600200"/>
+          </a:xfrm>
+          <a:prstGeom prst="roundRect">
+            <a:avLst>
+              <a:gd name="adj" fmla="val 8000"/>
+            </a:avLst>
+          </a:prstGeom>
+          <a:solidFill>
+            <a:srgbClr val="0F1F3D"/>
+          </a:solidFill>
+          <a:ln>
+            <a:noFill/>
+          </a:ln>
+          <a:effectLst/>
+        </p:spPr>
+        <p:style>
+          <a:lnRef idx="1">
+            <a:schemeClr val="accent1"/>
+          </a:lnRef>
+          <a:fillRef idx="3">
+            <a:schemeClr val="accent1"/>
+          </a:fillRef>
+          <a:effectRef idx="2">
+            <a:schemeClr val="accent1"/>
+          </a:effectRef>
+          <a:fontRef idx="minor">
+            <a:schemeClr val="lt1"/>
+          </a:fontRef>
+        </p:style>
+        <p:txBody>
+          <a:bodyPr rtlCol="0" anchor="ctr" wrap="square" tIns="54864" bIns="54864"/>
+          <a:lstStyle/>
+          <a:p>
+            <a:pPr algn="ctr">
+              <a:spcAft>
+                <a:spcPts val="300"/>
+              </a:spcAft>
+            </a:pPr>
+            <a:r>
+              <a:rPr sz="1700" b="1" i="0">
+                <a:solidFill>
+                  <a:srgbClr val="FFFFFF"/>
+                </a:solidFill>
+                <a:latin typeface="Calibri"/>
+              </a:rPr>
+              <a:t>Amazon Bedrock</a:t>
+            </a:r>
+          </a:p>
+          <a:p>
+            <a:pPr algn="ctr">
+              <a:spcAft>
+                <a:spcPts val="200"/>
+              </a:spcAft>
+            </a:pPr>
+            <a:r>
+              <a:rPr sz="1300" b="0" i="0">
+                <a:solidFill>
+                  <a:srgbClr val="FFFFFF"/>
+                </a:solidFill>
+                <a:latin typeface="Calibri"/>
+              </a:rPr>
+              <a:t>Nova 2 Lite</a:t>
+            </a:r>
+          </a:p>
+          <a:p>
+            <a:pPr algn="ctr">
+              <a:spcAft>
+                <a:spcPts val="200"/>
+              </a:spcAft>
+            </a:pPr>
+            <a:r>
+              <a:rPr sz="1300" b="0" i="0">
+                <a:solidFill>
+                  <a:srgbClr val="FFFFFF"/>
+                </a:solidFill>
+                <a:latin typeface="Calibri"/>
+              </a:rPr>
+              <a:t>ChatBedrockConverse</a:t>
+            </a:r>
+          </a:p>
+        </p:txBody>
+      </p:sp>
+      <p:sp>
+        <p:nvSpPr>
+          <p:cNvPr id="18" name="Rounded Rectangle 17"/>
+          <p:cNvSpPr/>
+          <p:nvPr/>
+        </p:nvSpPr>
+        <p:spPr>
+          <a:xfrm>
+            <a:off x="9189720" y="3977639"/>
+            <a:ext cx="2606040" cy="1188720"/>
+          </a:xfrm>
+          <a:prstGeom prst="roundRect">
+            <a:avLst>
+              <a:gd name="adj" fmla="val 8000"/>
+            </a:avLst>
+          </a:prstGeom>
+          <a:solidFill>
+            <a:srgbClr val="F1F5F9"/>
+          </a:solidFill>
+          <a:ln w="12700">
+            <a:solidFill>
+              <a:srgbClr val="CBD5E1"/>
+            </a:solidFill>
+          </a:ln>
+          <a:effectLst/>
+        </p:spPr>
+        <p:style>
+          <a:lnRef idx="1">
+            <a:schemeClr val="accent1"/>
+          </a:lnRef>
+          <a:fillRef idx="3">
+            <a:schemeClr val="accent1"/>
+          </a:fillRef>
+          <a:effectRef idx="2">
+            <a:schemeClr val="accent1"/>
+          </a:effectRef>
+          <a:fontRef idx="minor">
+            <a:schemeClr val="lt1"/>
+          </a:fontRef>
+        </p:style>
+        <p:txBody>
+          <a:bodyPr rtlCol="0" anchor="ctr" wrap="square" tIns="54864" bIns="54864"/>
+          <a:lstStyle/>
+          <a:p>
+            <a:pPr algn="ctr">
+              <a:spcAft>
+                <a:spcPts val="300"/>
+              </a:spcAft>
+            </a:pPr>
+            <a:r>
+              <a:rPr sz="1400" b="1" i="0">
+                <a:solidFill>
+                  <a:srgbClr val="0F1F3D"/>
+                </a:solidFill>
+                <a:latin typeface="Calibri"/>
+              </a:rPr>
+              <a:t>SSM Run Command</a:t>
+            </a:r>
+          </a:p>
+          <a:p>
+            <a:pPr algn="ctr">
+              <a:spcAft>
+                <a:spcPts val="200"/>
+              </a:spcAft>
+            </a:pPr>
+            <a:r>
+              <a:rPr sz="1200" b="0" i="0">
+                <a:solidFill>
+                  <a:srgbClr val="1F2937"/>
+                </a:solidFill>
+                <a:latin typeface="Calibri"/>
+              </a:rPr>
+              <a:t>runs redeploy.sh</a:t>
+            </a:r>
+          </a:p>
+          <a:p>
+            <a:pPr algn="ctr">
+              <a:spcAft>
+                <a:spcPts val="200"/>
+              </a:spcAft>
+            </a:pPr>
+            <a:r>
+              <a:rPr sz="1200" b="0" i="0">
+                <a:solidFill>
+                  <a:srgbClr val="1F2937"/>
+                </a:solidFill>
+                <a:latin typeface="Calibri"/>
+              </a:rPr>
+              <a:t>on the EC2 host</a:t>
+            </a:r>
+          </a:p>
+        </p:txBody>
+      </p:sp>
+      <p:cxnSp>
+        <p:nvCxnSpPr>
+          <p:cNvPr id="19" name="Connector 18"/>
+          <p:cNvCxnSpPr/>
+          <p:nvPr/>
+        </p:nvCxnSpPr>
+        <p:spPr>
+          <a:xfrm>
+            <a:off x="2057400" y="2697480"/>
+            <a:ext cx="960120" cy="0"/>
+          </a:xfrm>
+          <a:prstGeom prst="line">
+            <a:avLst/>
+          </a:prstGeom>
+          <a:ln w="25400">
+            <a:solidFill>
+              <a:srgbClr val="1C335E"/>
+            </a:solidFill>
+            <a:tailEnd type="triangle" w="med" len="med"/>
+          </a:ln>
+        </p:spPr>
+        <p:style>
+          <a:lnRef idx="2">
+            <a:schemeClr val="accent1"/>
+          </a:lnRef>
+          <a:fillRef idx="0">
+            <a:schemeClr val="accent1"/>
+          </a:fillRef>
+          <a:effectRef idx="1">
+            <a:schemeClr val="accent1"/>
+          </a:effectRef>
+          <a:fontRef idx="minor">
+            <a:schemeClr val="tx1"/>
+          </a:fontRef>
+        </p:style>
+      </p:cxnSp>
+      <p:sp>
+        <p:nvSpPr>
+          <p:cNvPr id="20" name="TextBox 19"/>
+          <p:cNvSpPr txBox="1"/>
+          <p:nvPr/>
+        </p:nvSpPr>
+        <p:spPr>
+          <a:xfrm>
+            <a:off x="2011680" y="2286000"/>
+            <a:ext cx="658368" cy="320040"/>
+          </a:xfrm>
+          <a:prstGeom prst="rect">
+            <a:avLst/>
+          </a:prstGeom>
+          <a:noFill/>
+        </p:spPr>
+        <p:txBody>
+          <a:bodyPr wrap="square" anchor="t" lIns="45720" rIns="45720">
+            <a:spAutoFit/>
+          </a:bodyPr>
+          <a:lstStyle/>
+          <a:p>
+            <a:pPr algn="ctr">
+              <a:spcAft>
+                <a:spcPts val="400"/>
+              </a:spcAft>
+            </a:pPr>
+            <a:r>
+              <a:rPr sz="1000" b="1" i="0">
+                <a:solidFill>
+                  <a:srgbClr val="556070"/>
+                </a:solidFill>
+                <a:latin typeface="Calibri"/>
+              </a:rPr>
+              <a:t>HTTP :80</a:t>
+            </a:r>
+          </a:p>
+        </p:txBody>
+      </p:sp>
+      <p:cxnSp>
+        <p:nvCxnSpPr>
+          <p:cNvPr id="21" name="Connector 20"/>
+          <p:cNvCxnSpPr/>
+          <p:nvPr/>
+        </p:nvCxnSpPr>
+        <p:spPr>
+          <a:xfrm>
+            <a:off x="5394960" y="2715768"/>
+            <a:ext cx="548640" cy="0"/>
+          </a:xfrm>
+          <a:prstGeom prst="line">
+            <a:avLst/>
+          </a:prstGeom>
+          <a:ln w="25400">
+            <a:solidFill>
+              <a:srgbClr val="1C335E"/>
+            </a:solidFill>
+            <a:tailEnd type="triangle" w="med" len="med"/>
+          </a:ln>
+        </p:spPr>
+        <p:style>
+          <a:lnRef idx="2">
+            <a:schemeClr val="accent1"/>
+          </a:lnRef>
+          <a:fillRef idx="0">
+            <a:schemeClr val="accent1"/>
+          </a:fillRef>
+          <a:effectRef idx="1">
+            <a:schemeClr val="accent1"/>
+          </a:effectRef>
+          <a:fontRef idx="minor">
+            <a:schemeClr val="tx1"/>
+          </a:fontRef>
+        </p:style>
+      </p:cxnSp>
+      <p:cxnSp>
+        <p:nvCxnSpPr>
+          <p:cNvPr id="22" name="Connector 21"/>
+          <p:cNvCxnSpPr/>
+          <p:nvPr/>
+        </p:nvCxnSpPr>
+        <p:spPr>
+          <a:xfrm>
+            <a:off x="8321040" y="2715768"/>
+            <a:ext cx="822960" cy="0"/>
+          </a:xfrm>
+          <a:prstGeom prst="line">
+            <a:avLst/>
+          </a:prstGeom>
+          <a:ln w="25400">
+            <a:solidFill>
+              <a:srgbClr val="1C335E"/>
+            </a:solidFill>
+            <a:tailEnd type="triangle" w="med" len="med"/>
+          </a:ln>
+        </p:spPr>
+        <p:style>
+          <a:lnRef idx="2">
+            <a:schemeClr val="accent1"/>
+          </a:lnRef>
+          <a:fillRef idx="0">
+            <a:schemeClr val="accent1"/>
+          </a:fillRef>
+          <a:effectRef idx="1">
+            <a:schemeClr val="accent1"/>
+          </a:effectRef>
+          <a:fontRef idx="minor">
+            <a:schemeClr val="tx1"/>
+          </a:fontRef>
+        </p:style>
+      </p:cxnSp>
+      <p:cxnSp>
+        <p:nvCxnSpPr>
+          <p:cNvPr id="23" name="Connector 22"/>
+          <p:cNvCxnSpPr/>
+          <p:nvPr/>
+        </p:nvCxnSpPr>
+        <p:spPr>
+          <a:xfrm>
+            <a:off x="2057400" y="4572000"/>
+            <a:ext cx="777240" cy="0"/>
+          </a:xfrm>
+          <a:prstGeom prst="line">
+            <a:avLst/>
+          </a:prstGeom>
+          <a:ln w="25400">
+            <a:solidFill>
+              <a:srgbClr val="1C335E"/>
+            </a:solidFill>
+            <a:tailEnd type="triangle" w="med" len="med"/>
+          </a:ln>
+        </p:spPr>
+        <p:style>
+          <a:lnRef idx="2">
+            <a:schemeClr val="accent1"/>
+          </a:lnRef>
+          <a:fillRef idx="0">
+            <a:schemeClr val="accent1"/>
+          </a:fillRef>
+          <a:effectRef idx="1">
+            <a:schemeClr val="accent1"/>
+          </a:effectRef>
+          <a:fontRef idx="minor">
+            <a:schemeClr val="tx1"/>
+          </a:fontRef>
+        </p:style>
+      </p:cxnSp>
+      <p:cxnSp>
+        <p:nvCxnSpPr>
+          <p:cNvPr id="24" name="Connector 23"/>
+          <p:cNvCxnSpPr/>
+          <p:nvPr/>
+        </p:nvCxnSpPr>
+        <p:spPr>
+          <a:xfrm flipV="1">
+            <a:off x="4251960" y="3337560"/>
+            <a:ext cx="0" cy="338327"/>
+          </a:xfrm>
+          <a:prstGeom prst="line">
+            <a:avLst/>
+          </a:prstGeom>
+          <a:ln w="25400">
+            <a:solidFill>
+              <a:srgbClr val="1C335E"/>
+            </a:solidFill>
+            <a:tailEnd type="triangle" w="med" len="med"/>
+          </a:ln>
+        </p:spPr>
+        <p:style>
+          <a:lnRef idx="2">
+            <a:schemeClr val="accent1"/>
+          </a:lnRef>
+          <a:fillRef idx="0">
+            <a:schemeClr val="accent1"/>
+          </a:fillRef>
+          <a:effectRef idx="1">
+            <a:schemeClr val="accent1"/>
+          </a:effectRef>
+          <a:fontRef idx="minor">
+            <a:schemeClr val="tx1"/>
+          </a:fontRef>
+        </p:style>
+      </p:cxnSp>
+      <p:cxnSp>
+        <p:nvCxnSpPr>
+          <p:cNvPr id="25" name="Connector 24"/>
+          <p:cNvCxnSpPr/>
+          <p:nvPr/>
+        </p:nvCxnSpPr>
+        <p:spPr>
+          <a:xfrm flipV="1">
+            <a:off x="8321040" y="3566160"/>
+            <a:ext cx="1371600" cy="548640"/>
+          </a:xfrm>
+          <a:prstGeom prst="line">
+            <a:avLst/>
+          </a:prstGeom>
+          <a:ln w="25400">
+            <a:solidFill>
+              <a:srgbClr val="F59E0B"/>
+            </a:solidFill>
+            <a:tailEnd type="triangle" w="med" len="med"/>
+          </a:ln>
+        </p:spPr>
+        <p:style>
+          <a:lnRef idx="2">
+            <a:schemeClr val="accent1"/>
+          </a:lnRef>
+          <a:fillRef idx="0">
+            <a:schemeClr val="accent1"/>
+          </a:fillRef>
+          <a:effectRef idx="1">
+            <a:schemeClr val="accent1"/>
+          </a:effectRef>
+          <a:fontRef idx="minor">
+            <a:schemeClr val="tx1"/>
+          </a:fontRef>
+        </p:style>
+      </p:cxnSp>
+      <p:cxnSp>
+        <p:nvCxnSpPr>
+          <p:cNvPr id="26" name="Connector 25"/>
+          <p:cNvCxnSpPr/>
+          <p:nvPr/>
+        </p:nvCxnSpPr>
+        <p:spPr>
+          <a:xfrm flipH="1">
+            <a:off x="8668512" y="4754880"/>
+            <a:ext cx="475488" cy="0"/>
+          </a:xfrm>
+          <a:prstGeom prst="line">
+            <a:avLst/>
+          </a:prstGeom>
+          <a:ln w="19050">
+            <a:solidFill>
+              <a:srgbClr val="556070"/>
+            </a:solidFill>
+            <a:tailEnd type="triangle" w="med" len="med"/>
+          </a:ln>
+        </p:spPr>
+        <p:style>
+          <a:lnRef idx="2">
+            <a:schemeClr val="accent1"/>
+          </a:lnRef>
+          <a:fillRef idx="0">
+            <a:schemeClr val="accent1"/>
+          </a:fillRef>
+          <a:effectRef idx="1">
+            <a:schemeClr val="accent1"/>
+          </a:effectRef>
+          <a:fontRef idx="minor">
+            <a:schemeClr val="tx1"/>
+          </a:fontRef>
+        </p:style>
+      </p:cxnSp>
+      <p:sp>
+        <p:nvSpPr>
+          <p:cNvPr id="27" name="Rounded Rectangle 26"/>
+          <p:cNvSpPr/>
+          <p:nvPr/>
+        </p:nvSpPr>
+        <p:spPr>
+          <a:xfrm>
+            <a:off x="365760" y="5486400"/>
+            <a:ext cx="11430000" cy="868680"/>
+          </a:xfrm>
+          <a:prstGeom prst="roundRect">
+            <a:avLst>
+              <a:gd name="adj" fmla="val 8000"/>
+            </a:avLst>
+          </a:prstGeom>
+          <a:solidFill>
+            <a:srgbClr val="0F1F3D"/>
+          </a:solidFill>
+          <a:ln>
+            <a:noFill/>
+          </a:ln>
+          <a:effectLst/>
+        </p:spPr>
+        <p:style>
+          <a:lnRef idx="1">
+            <a:schemeClr val="accent1"/>
+          </a:lnRef>
+          <a:fillRef idx="3">
+            <a:schemeClr val="accent1"/>
+          </a:fillRef>
+          <a:effectRef idx="2">
+            <a:schemeClr val="accent1"/>
+          </a:effectRef>
+          <a:fontRef idx="minor">
+            <a:schemeClr val="lt1"/>
+          </a:fontRef>
+        </p:style>
+        <p:txBody>
+          <a:bodyPr rtlCol="0" anchor="ctr"/>
+          <a:lstStyle/>
+          <a:p/>
+        </p:txBody>
+      </p:sp>
+      <p:sp>
+        <p:nvSpPr>
+          <p:cNvPr id="28" name="TextBox 27"/>
+          <p:cNvSpPr txBox="1"/>
+          <p:nvPr/>
+        </p:nvSpPr>
+        <p:spPr>
+          <a:xfrm>
+            <a:off x="548640" y="5513832"/>
+            <a:ext cx="11064240" cy="411480"/>
+          </a:xfrm>
+          <a:prstGeom prst="rect">
+            <a:avLst/>
+          </a:prstGeom>
+          <a:noFill/>
+        </p:spPr>
+        <p:txBody>
+          <a:bodyPr wrap="square" anchor="ctr" lIns="45720" rIns="45720">
+            <a:spAutoFit/>
+          </a:bodyPr>
+          <a:lstStyle/>
+          <a:p>
+            <a:pPr algn="l">
+              <a:spcAft>
+                <a:spcPts val="400"/>
+              </a:spcAft>
+            </a:pPr>
+            <a:r>
+              <a:rPr sz="2000" b="1" i="0">
+                <a:solidFill>
+                  <a:srgbClr val="FFFFFF"/>
+                </a:solidFill>
+                <a:latin typeface="Calibri"/>
+              </a:rPr>
+              <a:t>Live demo:  http://15.207.159.211</a:t>
+            </a:r>
+          </a:p>
+        </p:txBody>
+      </p:sp>
+      <p:sp>
+        <p:nvSpPr>
+          <p:cNvPr id="29" name="TextBox 28"/>
+          <p:cNvSpPr txBox="1"/>
+          <p:nvPr/>
+        </p:nvSpPr>
+        <p:spPr>
+          <a:xfrm>
+            <a:off x="548640" y="5916168"/>
+            <a:ext cx="11064240" cy="384048"/>
+          </a:xfrm>
+          <a:prstGeom prst="rect">
+            <a:avLst/>
+          </a:prstGeom>
+          <a:noFill/>
+        </p:spPr>
+        <p:txBody>
+          <a:bodyPr wrap="square" anchor="ctr" lIns="45720" rIns="45720">
+            <a:spAutoFit/>
+          </a:bodyPr>
+          <a:lstStyle/>
+          <a:p>
+            <a:pPr algn="l">
+              <a:spcAft>
+                <a:spcPts val="400"/>
+              </a:spcAft>
+            </a:pPr>
+            <a:r>
+              <a:rPr sz="1400" b="0" i="0">
+                <a:solidFill>
+                  <a:srgbClr val="CBD5E1"/>
+                </a:solidFill>
+                <a:latin typeface="Calibri"/>
+              </a:rPr>
+              <a:t>Sample or uploaded docs  •  metrics + report table  •  per-document tabs  •  CSV + zip download  •  run limits</a:t>
+            </a:r>
+          </a:p>
+        </p:txBody>
+      </p:sp>
+    </p:spTree>
+  </p:cSld>
+  <p:clrMapOvr>
+    <a:masterClrMapping/>
+  </p:clrMapOvr>
+</p:sld>
+</file>
+
+<file path=ppt/slides/slide13.xml><?xml version="1.0" encoding="utf-8"?>
+<p:sld xmlns:a="http://schemas.openxmlformats.org/drawingml/2006/main" xmlns:p="http://schemas.openxmlformats.org/presentationml/2006/main" xmlns:r="http://schemas.openxmlformats.org/officeDocument/2006/relationships">
+  <p:cSld>
+    <p:bg>
+      <p:bgPr>
+        <a:solidFill>
+          <a:srgbClr val="FFFFFF"/>
+        </a:solidFill>
+        <a:effectLst/>
+      </p:bgPr>
+    </p:bg>
+    <p:spTree>
+      <p:nvGrpSpPr>
+        <p:cNvPr id="1" name=""/>
+        <p:cNvGrpSpPr/>
+        <p:nvPr/>
+      </p:nvGrpSpPr>
+      <p:grpSpPr/>
+      <p:sp>
+        <p:nvSpPr>
+          <p:cNvPr id="2" name="TitleBar"/>
+          <p:cNvSpPr/>
+          <p:nvPr/>
+        </p:nvSpPr>
+        <p:spPr>
+          <a:xfrm>
+            <a:off x="0" y="0"/>
+            <a:ext cx="12191695" cy="960120"/>
+          </a:xfrm>
+          <a:prstGeom prst="rect">
+            <a:avLst/>
+          </a:prstGeom>
+          <a:solidFill>
+            <a:srgbClr val="0F1F3D"/>
+          </a:solidFill>
+          <a:ln>
+            <a:noFill/>
+          </a:ln>
+          <a:effectLst/>
+        </p:spPr>
+        <p:style>
+          <a:lnRef idx="1">
+            <a:schemeClr val="accent1"/>
+          </a:lnRef>
+          <a:fillRef idx="3">
+            <a:schemeClr val="accent1"/>
+          </a:fillRef>
+          <a:effectRef idx="2">
+            <a:schemeClr val="accent1"/>
+          </a:effectRef>
+          <a:fontRef idx="minor">
+            <a:schemeClr val="lt1"/>
+          </a:fontRef>
+        </p:style>
+        <p:txBody>
+          <a:bodyPr rtlCol="0" anchor="ctr"/>
+          <a:lstStyle/>
+          <a:p/>
+        </p:txBody>
+      </p:sp>
+      <p:sp>
+        <p:nvSpPr>
+          <p:cNvPr id="3" name="Rectangle 2"/>
+          <p:cNvSpPr/>
+          <p:nvPr/>
+        </p:nvSpPr>
+        <p:spPr>
+          <a:xfrm>
+            <a:off x="0" y="960120"/>
+            <a:ext cx="12191695" cy="54864"/>
+          </a:xfrm>
+          <a:prstGeom prst="rect">
+            <a:avLst/>
+          </a:prstGeom>
+          <a:solidFill>
+            <a:srgbClr val="14B8A6"/>
+          </a:solidFill>
+          <a:ln>
+            <a:noFill/>
+          </a:ln>
+          <a:effectLst/>
+        </p:spPr>
+        <p:style>
+          <a:lnRef idx="1">
+            <a:schemeClr val="accent1"/>
+          </a:lnRef>
+          <a:fillRef idx="3">
+            <a:schemeClr val="accent1"/>
+          </a:fillRef>
+          <a:effectRef idx="2">
+            <a:schemeClr val="accent1"/>
+          </a:effectRef>
+          <a:fontRef idx="minor">
+            <a:schemeClr val="lt1"/>
+          </a:fontRef>
+        </p:style>
+        <p:txBody>
+          <a:bodyPr rtlCol="0" anchor="ctr"/>
+          <a:lstStyle/>
+          <a:p/>
+        </p:txBody>
+      </p:sp>
+      <p:sp>
+        <p:nvSpPr>
+          <p:cNvPr id="4" name="TextBox 3"/>
+          <p:cNvSpPr txBox="1"/>
+          <p:nvPr/>
+        </p:nvSpPr>
+        <p:spPr>
+          <a:xfrm>
+            <a:off x="457200" y="109728"/>
+            <a:ext cx="9875520" cy="731520"/>
+          </a:xfrm>
+          <a:prstGeom prst="rect">
+            <a:avLst/>
+          </a:prstGeom>
+          <a:noFill/>
+        </p:spPr>
+        <p:txBody>
+          <a:bodyPr wrap="square" anchor="ctr" lIns="45720" rIns="45720">
+            <a:spAutoFit/>
+          </a:bodyPr>
+          <a:lstStyle/>
+          <a:p>
+            <a:pPr algn="l">
+              <a:spcAft>
+                <a:spcPts val="400"/>
+              </a:spcAft>
+            </a:pPr>
+            <a:r>
+              <a:rPr sz="3000" b="1" i="0">
+                <a:solidFill>
+                  <a:srgbClr val="FFFFFF"/>
+                </a:solidFill>
+                <a:latin typeface="Calibri"/>
+              </a:rPr>
+              <a:t>Limitations &amp; Future Work</a:t>
+            </a:r>
+          </a:p>
+        </p:txBody>
+      </p:sp>
+      <p:sp>
+        <p:nvSpPr>
+          <p:cNvPr id="5" name="TextBox 4"/>
+          <p:cNvSpPr txBox="1"/>
+          <p:nvPr/>
+        </p:nvSpPr>
+        <p:spPr>
+          <a:xfrm>
+            <a:off x="457200" y="6446520"/>
+            <a:ext cx="8229600" cy="320040"/>
+          </a:xfrm>
+          <a:prstGeom prst="rect">
+            <a:avLst/>
+          </a:prstGeom>
+          <a:noFill/>
+        </p:spPr>
+        <p:txBody>
+          <a:bodyPr wrap="square" anchor="t" lIns="45720" rIns="45720">
+            <a:spAutoFit/>
+          </a:bodyPr>
+          <a:lstStyle/>
+          <a:p>
+            <a:pPr algn="l">
+              <a:spcAft>
+                <a:spcPts val="400"/>
+              </a:spcAft>
+            </a:pPr>
+            <a:r>
+              <a:rPr sz="1100" b="0" i="0">
+                <a:solidFill>
+                  <a:srgbClr val="556070"/>
+                </a:solidFill>
+                <a:latin typeface="Calibri"/>
+              </a:rPr>
+              <a:t>AI Customer Complaint &amp; Case Processing System  |  Saurabh Goyal</a:t>
+            </a:r>
+          </a:p>
+        </p:txBody>
+      </p:sp>
+      <p:sp>
+        <p:nvSpPr>
+          <p:cNvPr id="6" name="TextBox 5"/>
+          <p:cNvSpPr txBox="1"/>
+          <p:nvPr/>
+        </p:nvSpPr>
+        <p:spPr>
+          <a:xfrm>
+            <a:off x="10789920" y="6446520"/>
+            <a:ext cx="941832" cy="320040"/>
+          </a:xfrm>
+          <a:prstGeom prst="rect">
+            <a:avLst/>
+          </a:prstGeom>
+          <a:noFill/>
+        </p:spPr>
+        <p:txBody>
+          <a:bodyPr wrap="square" anchor="t" lIns="45720" rIns="45720">
+            <a:spAutoFit/>
+          </a:bodyPr>
+          <a:lstStyle/>
+          <a:p>
+            <a:pPr algn="r">
+              <a:spcAft>
+                <a:spcPts val="400"/>
+              </a:spcAft>
+            </a:pPr>
+            <a:r>
+              <a:rPr sz="1100" b="0" i="0">
+                <a:solidFill>
+                  <a:srgbClr val="556070"/>
+                </a:solidFill>
+                <a:latin typeface="Calibri"/>
+              </a:rPr>
+              <a:t>13 / 13</a:t>
+            </a:r>
+          </a:p>
+        </p:txBody>
+      </p:sp>
+      <p:sp>
+        <p:nvSpPr>
+          <p:cNvPr id="7" name="TextBox 6"/>
+          <p:cNvSpPr txBox="1"/>
+          <p:nvPr/>
+        </p:nvSpPr>
+        <p:spPr>
+          <a:xfrm>
+            <a:off x="457200" y="1188720"/>
+            <a:ext cx="5394960" cy="502920"/>
+          </a:xfrm>
+          <a:prstGeom prst="rect">
+            <a:avLst/>
+          </a:prstGeom>
+          <a:noFill/>
+        </p:spPr>
+        <p:txBody>
+          <a:bodyPr wrap="square" anchor="t" lIns="45720" rIns="45720">
+            <a:spAutoFit/>
+          </a:bodyPr>
+          <a:lstStyle/>
+          <a:p>
             <a:pPr algn="l">
               <a:spcAft>
                 <a:spcPts val="400"/>
@@ -8035,7 +9987,7 @@
                 </a:solidFill>
                 <a:latin typeface="Calibri"/>
               </a:rPr>
-              <a:t>Local model: ~58 s per document</a:t>
+              <a:t>Local model: ~58 s/doc (Bedrock ~4 s)</a:t>
             </a:r>
           </a:p>
           <a:p>
@@ -8197,7 +10149,7 @@
                 </a:solidFill>
                 <a:latin typeface="Calibri"/>
               </a:rPr>
-              <a:t>Human-in-the-loop review UI + REST API</a:t>
+              <a:t>Review/approve in the UI, HTTPS + auth</a:t>
             </a:r>
           </a:p>
           <a:p>
@@ -8594,7 +10546,7 @@
                 </a:solidFill>
                 <a:latin typeface="Calibri"/>
               </a:rPr>
-              <a:t>2 / 12</a:t>
+              <a:t>2 / 13</a:t>
             </a:r>
           </a:p>
         </p:txBody>
@@ -9421,7 +11373,7 @@
                 </a:solidFill>
                 <a:latin typeface="Calibri"/>
               </a:rPr>
-              <a:t>3 / 12</a:t>
+              <a:t>3 / 13</a:t>
             </a:r>
           </a:p>
         </p:txBody>
@@ -10505,7 +12457,7 @@
                 </a:solidFill>
                 <a:latin typeface="Calibri"/>
               </a:rPr>
-              <a:t>4 / 12</a:t>
+              <a:t>4 / 13</a:t>
             </a:r>
           </a:p>
         </p:txBody>
@@ -11644,7 +13596,7 @@
                 </a:solidFill>
                 <a:latin typeface="Calibri"/>
               </a:rPr>
-              <a:t>OpenAI  •  Gemini  •  Ollama (local)</a:t>
+              <a:t>OpenAI  •  Gemini  •  Ollama (local)  •  AWS Bedrock</a:t>
             </a:r>
           </a:p>
         </p:txBody>
@@ -12165,7 +14117,7 @@
                 </a:solidFill>
                 <a:latin typeface="Calibri"/>
               </a:rPr>
-              <a:t>5 / 12</a:t>
+              <a:t>5 / 13</a:t>
             </a:r>
           </a:p>
         </p:txBody>
@@ -12782,7 +14734,7 @@
                 </a:solidFill>
                 <a:latin typeface="Calibri"/>
               </a:rPr>
-              <a:t>email 35.8 s ‖ summary 30.0 s, concurrent</a:t>
+              <a:t>email 29.8 s ‖ summary 23.2 s, concurrent</a:t>
             </a:r>
           </a:p>
         </p:txBody>
@@ -13004,210 +14956,14 @@
                 </a:solidFill>
                 <a:latin typeface="Consolas"/>
               </a:rPr>
-              <a:t>001 → 005</a:t>
-            </a:r>
-          </a:p>
-        </p:txBody>
-      </p:sp>
-      <p:sp>
-        <p:nvSpPr>
-          <p:cNvPr id="22" name="Rounded Rectangle 21"/>
-          <p:cNvSpPr/>
-          <p:nvPr/>
-        </p:nvSpPr>
-        <p:spPr>
-          <a:xfrm>
-            <a:off x="7589520" y="2715768"/>
-            <a:ext cx="1920240" cy="548640"/>
-          </a:xfrm>
-          <a:prstGeom prst="roundRect">
-            <a:avLst>
-              <a:gd name="adj" fmla="val 8000"/>
-            </a:avLst>
-          </a:prstGeom>
-          <a:solidFill>
-            <a:srgbClr val="1C335E"/>
-          </a:solidFill>
-          <a:ln>
-            <a:noFill/>
-          </a:ln>
-          <a:effectLst/>
-        </p:spPr>
-        <p:style>
-          <a:lnRef idx="1">
-            <a:schemeClr val="accent1"/>
-          </a:lnRef>
-          <a:fillRef idx="3">
-            <a:schemeClr val="accent1"/>
-          </a:fillRef>
-          <a:effectRef idx="2">
-            <a:schemeClr val="accent1"/>
-          </a:effectRef>
-          <a:fontRef idx="minor">
-            <a:schemeClr val="lt1"/>
-          </a:fontRef>
-        </p:style>
-        <p:txBody>
-          <a:bodyPr rtlCol="0" anchor="ctr" wrap="square" tIns="54864" bIns="54864"/>
-          <a:lstStyle/>
-          <a:p>
-            <a:pPr algn="ctr">
-              <a:spcAft>
-                <a:spcPts val="300"/>
-              </a:spcAft>
-            </a:pPr>
-            <a:r>
-              <a:rPr sz="1300" b="1" i="0">
-                <a:solidFill>
-                  <a:srgbClr val="FFFFFF"/>
-                </a:solidFill>
-                <a:latin typeface="Calibri"/>
-              </a:rPr>
-              <a:t>doc-worker_1</a:t>
-            </a:r>
-          </a:p>
-        </p:txBody>
-      </p:sp>
-      <p:sp>
-        <p:nvSpPr>
-          <p:cNvPr id="23" name="TextBox 22"/>
-          <p:cNvSpPr txBox="1"/>
-          <p:nvPr/>
-        </p:nvSpPr>
-        <p:spPr>
-          <a:xfrm>
-            <a:off x="9601200" y="2715768"/>
-            <a:ext cx="2011680" cy="548640"/>
-          </a:xfrm>
-          <a:prstGeom prst="rect">
-            <a:avLst/>
-          </a:prstGeom>
-          <a:noFill/>
-        </p:spPr>
-        <p:txBody>
-          <a:bodyPr wrap="square" anchor="ctr" lIns="45720" rIns="45720">
-            <a:spAutoFit/>
-          </a:bodyPr>
-          <a:lstStyle/>
-          <a:p>
-            <a:pPr algn="l">
-              <a:spcAft>
-                <a:spcPts val="400"/>
-              </a:spcAft>
-            </a:pPr>
-            <a:r>
-              <a:rPr sz="1600" b="0" i="0">
-                <a:solidFill>
-                  <a:srgbClr val="1F2937"/>
-                </a:solidFill>
-                <a:latin typeface="Consolas"/>
-              </a:rPr>
-              <a:t>002 → 006</a:t>
-            </a:r>
-          </a:p>
-        </p:txBody>
-      </p:sp>
-      <p:sp>
-        <p:nvSpPr>
-          <p:cNvPr id="24" name="Rounded Rectangle 23"/>
-          <p:cNvSpPr/>
-          <p:nvPr/>
-        </p:nvSpPr>
-        <p:spPr>
-          <a:xfrm>
-            <a:off x="7589520" y="3374136"/>
-            <a:ext cx="1920240" cy="548640"/>
-          </a:xfrm>
-          <a:prstGeom prst="roundRect">
-            <a:avLst>
-              <a:gd name="adj" fmla="val 8000"/>
-            </a:avLst>
-          </a:prstGeom>
-          <a:solidFill>
-            <a:srgbClr val="1C335E"/>
-          </a:solidFill>
-          <a:ln>
-            <a:noFill/>
-          </a:ln>
-          <a:effectLst/>
-        </p:spPr>
-        <p:style>
-          <a:lnRef idx="1">
-            <a:schemeClr val="accent1"/>
-          </a:lnRef>
-          <a:fillRef idx="3">
-            <a:schemeClr val="accent1"/>
-          </a:fillRef>
-          <a:effectRef idx="2">
-            <a:schemeClr val="accent1"/>
-          </a:effectRef>
-          <a:fontRef idx="minor">
-            <a:schemeClr val="lt1"/>
-          </a:fontRef>
-        </p:style>
-        <p:txBody>
-          <a:bodyPr rtlCol="0" anchor="ctr" wrap="square" tIns="54864" bIns="54864"/>
-          <a:lstStyle/>
-          <a:p>
-            <a:pPr algn="ctr">
-              <a:spcAft>
-                <a:spcPts val="300"/>
-              </a:spcAft>
-            </a:pPr>
-            <a:r>
-              <a:rPr sz="1300" b="1" i="0">
-                <a:solidFill>
-                  <a:srgbClr val="FFFFFF"/>
-                </a:solidFill>
-                <a:latin typeface="Calibri"/>
-              </a:rPr>
-              <a:t>doc-worker_2</a:t>
-            </a:r>
-          </a:p>
-        </p:txBody>
-      </p:sp>
-      <p:sp>
-        <p:nvSpPr>
-          <p:cNvPr id="25" name="TextBox 24"/>
-          <p:cNvSpPr txBox="1"/>
-          <p:nvPr/>
-        </p:nvSpPr>
-        <p:spPr>
-          <a:xfrm>
-            <a:off x="9601200" y="3374136"/>
-            <a:ext cx="2011680" cy="548640"/>
-          </a:xfrm>
-          <a:prstGeom prst="rect">
-            <a:avLst/>
-          </a:prstGeom>
-          <a:noFill/>
-        </p:spPr>
-        <p:txBody>
-          <a:bodyPr wrap="square" anchor="ctr" lIns="45720" rIns="45720">
-            <a:spAutoFit/>
-          </a:bodyPr>
-          <a:lstStyle/>
-          <a:p>
-            <a:pPr algn="l">
-              <a:spcAft>
-                <a:spcPts val="400"/>
-              </a:spcAft>
-            </a:pPr>
-            <a:r>
-              <a:rPr sz="1600" b="0" i="0">
-                <a:solidFill>
-                  <a:srgbClr val="1F2937"/>
-                </a:solidFill>
-                <a:latin typeface="Consolas"/>
-              </a:rPr>
-              <a:t>003 → 004</a:t>
-            </a:r>
-          </a:p>
-        </p:txBody>
-      </p:sp>
-      <p:sp>
-        <p:nvSpPr>
-          <p:cNvPr id="26" name="TextBox 25"/>
+              <a:t>003</a:t>
+            </a:r>
+          </a:p>
+        </p:txBody>
+      </p:sp>
+      <p:sp>
+        <p:nvSpPr>
+          <p:cNvPr id="22" name="TextBox 21"/>
           <p:cNvSpPr txBox="1"/>
           <p:nvPr/>
         </p:nvSpPr>
@@ -13514,7 +15270,7 @@
                 </a:solidFill>
                 <a:latin typeface="Calibri"/>
               </a:rPr>
-              <a:t>6 / 12</a:t>
+              <a:t>6 / 13</a:t>
             </a:r>
           </a:p>
         </p:txBody>
@@ -14924,7 +16680,7 @@
                 </a:solidFill>
                 <a:latin typeface="Calibri"/>
               </a:rPr>
-              <a:t>7 / 12</a:t>
+              <a:t>7 / 13</a:t>
             </a:r>
           </a:p>
         </p:txBody>
@@ -15953,7 +17709,7 @@
                 </a:solidFill>
                 <a:latin typeface="Calibri"/>
               </a:rPr>
-              <a:t>8 / 12</a:t>
+              <a:t>8 / 13</a:t>
             </a:r>
           </a:p>
         </p:txBody>
@@ -16433,7 +18189,7 @@
                 </a:solidFill>
                 <a:latin typeface="Calibri"/>
               </a:rPr>
-              <a:t>LLM timeouts + max_retries; native → fallback → retry</a:t>
+              <a:t>LLM timeouts + max_retries (botocore retries on Bedrock); native → fallback → retry</a:t>
             </a:r>
           </a:p>
         </p:txBody>
@@ -16771,7 +18527,7 @@
                 </a:solidFill>
                 <a:latin typeface="Consolas"/>
               </a:rPr>
-              <a:t>ok in 24.30s (category=Billing)</a:t>
+              <a:t>ok in 10.71s (category=Billing)</a:t>
             </a:r>
           </a:p>
           <a:p>
@@ -16787,7 +18543,7 @@
                 </a:solidFill>
                 <a:latin typeface="Consolas"/>
               </a:rPr>
-              <a:t>[complaint_001] step 2/2 email ok 35.77s</a:t>
+              <a:t>[complaint_001] step 2/2 email ok 29.79s</a:t>
             </a:r>
           </a:p>
           <a:p>
@@ -16803,7 +18559,7 @@
                 </a:solidFill>
                 <a:latin typeface="Consolas"/>
               </a:rPr>
-              <a:t>[complaint_001] step 2/2 summary ok 30.04s</a:t>
+              <a:t>[complaint_001] step 2/2 summary ok 23.21s</a:t>
             </a:r>
           </a:p>
           <a:p>
@@ -16819,7 +18575,7 @@
                 </a:solidFill>
                 <a:latin typeface="Consolas"/>
               </a:rPr>
-              <a:t>[2/6] complaint_001.pdf done (success, 60.1s)</a:t>
+              <a:t>[1/6] complaint_001.pdf done (success, 40.5s)</a:t>
             </a:r>
           </a:p>
         </p:txBody>
@@ -17101,7 +18857,7 @@
                 </a:solidFill>
                 <a:latin typeface="Calibri"/>
               </a:rPr>
-              <a:t>9 / 12</a:t>
+              <a:t>9 / 13</a:t>
             </a:r>
           </a:p>
         </p:txBody>

</xml_diff>